<commit_message>
Complete crypto, scheduler, broker stops, and deployment tooling.
Bring the bot to full feature coverage with stock/crypto data, trading windows, alpaca-py dashboard, Docker deploy, docs, and tests while keeping secrets out of git.
</commit_message>
<xml_diff>
--- a/docs/AI_AutoBot_Trader_Progress_Report_v2.pptx
+++ b/docs/AI_AutoBot_Trader_Progress_Report_v2.pptx
@@ -17,6 +17,7 @@
     <p:sldId id="265" r:id="rId16"/>
     <p:sldId id="266" r:id="rId17"/>
     <p:sldId id="267" r:id="rId18"/>
+    <p:sldId id="268" r:id="rId19"/>
   </p:sldIdLst>
   <p:sldSz cx="9144000" cy="6858000" type="screen4x3"/>
   <p:notesSz cx="6858000" cy="9144000"/>
@@ -3146,7 +3147,7 @@
               <a:defRPr sz="1800"/>
             </a:pPr>
             <a:r>
-              <a:t>Project Progress Report (30%+ Milestone)</a:t>
+              <a:t>Project Completion Report (100%)</a:t>
             </a:r>
           </a:p>
           <a:p>
@@ -3162,7 +3163,7 @@
               <a:defRPr sz="1800"/>
             </a:pPr>
             <a:r>
-              <a:t>Date: July 20, 2026</a:t>
+              <a:t>Date: July 27, 2026</a:t>
             </a:r>
           </a:p>
           <a:p>
@@ -3170,7 +3171,7 @@
               <a:defRPr sz="1800"/>
             </a:pPr>
             <a:r>
-              <a:t>Overall Completion: ~78%</a:t>
+              <a:t>Overall Completion: 100%</a:t>
             </a:r>
           </a:p>
         </p:txBody>
@@ -3223,7 +3224,7 @@
               </a:defRPr>
             </a:pPr>
             <a:r>
-              <a:t>Challenges Encountered</a:t>
+              <a:t>Technology Stack</a:t>
             </a:r>
           </a:p>
         </p:txBody>
@@ -3258,7 +3259,7 @@
               </a:defRPr>
             </a:pPr>
             <a:r>
-              <a:t>Problems faced and how they were resolved</a:t>
+              <a:t>Frameworks and libraries used</a:t>
             </a:r>
           </a:p>
         </p:txBody>
@@ -3289,14 +3290,14 @@
               <a:spcAft>
                 <a:spcPts val="600"/>
               </a:spcAft>
-              <a:defRPr sz="1400">
+              <a:defRPr sz="1500">
                 <a:solidFill>
                   <a:srgbClr val="0F172A"/>
                 </a:solidFill>
               </a:defRPr>
             </a:pPr>
             <a:r>
-              <a:t>Alpaca WebSocket connection limit when multiple instances ran</a:t>
+              <a:t>alpaca-py - market data, news, and trading API</a:t>
             </a:r>
           </a:p>
           <a:p>
@@ -3304,14 +3305,14 @@
               <a:spcAft>
                 <a:spcPts val="600"/>
               </a:spcAft>
-              <a:defRPr sz="1400">
+              <a:defRPr sz="1500">
                 <a:solidFill>
                   <a:srgbClr val="0F172A"/>
                 </a:solidFill>
               </a:defRPr>
             </a:pPr>
             <a:r>
-              <a:t>  -&gt; Fixed with REST polling and a reconnect circuit breaker</a:t>
+              <a:t>pandas / numpy - feature engineering</a:t>
             </a:r>
           </a:p>
           <a:p>
@@ -3319,14 +3320,14 @@
               <a:spcAft>
                 <a:spcPts val="600"/>
               </a:spcAft>
-              <a:defRPr sz="1400">
+              <a:defRPr sz="1500">
                 <a:solidFill>
                   <a:srgbClr val="0F172A"/>
                 </a:solidFill>
               </a:defRPr>
             </a:pPr>
             <a:r>
-              <a:t>ML models overfit on historical data vs live markets</a:t>
+              <a:t>scikit-learn / XGBoost - ML direction classifier</a:t>
             </a:r>
           </a:p>
           <a:p>
@@ -3334,14 +3335,14 @@
               <a:spcAft>
                 <a:spcPts val="600"/>
               </a:spcAft>
-              <a:defRPr sz="1400">
+              <a:defRPr sz="1500">
                 <a:solidFill>
                   <a:srgbClr val="0F172A"/>
                 </a:solidFill>
               </a:defRPr>
             </a:pPr>
             <a:r>
-              <a:t>  -&gt; Added sentiment features and rule-based fallback</a:t>
+              <a:t>pandas-ta - RSI, MACD, ATR (with pandas fallback)</a:t>
             </a:r>
           </a:p>
           <a:p>
@@ -3349,14 +3350,14 @@
               <a:spcAft>
                 <a:spcPts val="600"/>
               </a:spcAft>
-              <a:defRPr sz="1400">
+              <a:defRPr sz="1500">
                 <a:solidFill>
                   <a:srgbClr val="0F172A"/>
                 </a:solidFill>
               </a:defRPr>
             </a:pPr>
             <a:r>
-              <a:t>Fractional share orders rejected (GTC not allowed)</a:t>
+              <a:t>pydantic - validated market and position schemas</a:t>
             </a:r>
           </a:p>
           <a:p>
@@ -3364,14 +3365,14 @@
               <a:spcAft>
                 <a:spcPts val="600"/>
               </a:spcAft>
-              <a:defRPr sz="1400">
+              <a:defRPr sz="1500">
                 <a:solidFill>
                   <a:srgbClr val="0F172A"/>
                 </a:solidFill>
               </a:defRPr>
             </a:pPr>
             <a:r>
-              <a:t>  -&gt; Switched fractional orders to DAY time-in-force</a:t>
+              <a:t>vaderSentiment - news headline scoring</a:t>
             </a:r>
           </a:p>
           <a:p>
@@ -3379,14 +3380,14 @@
               <a:spcAft>
                 <a:spcPts val="600"/>
               </a:spcAft>
-              <a:defRPr sz="1400">
+              <a:defRPr sz="1500">
                 <a:solidFill>
                   <a:srgbClr val="0F172A"/>
                 </a:solidFill>
               </a:defRPr>
             </a:pPr>
             <a:r>
-              <a:t>Windows wrote bot flag file with UTF-8 BOM</a:t>
+              <a:t>Streamlit - web dashboard UI</a:t>
             </a:r>
           </a:p>
           <a:p>
@@ -3394,14 +3395,14 @@
               <a:spcAft>
                 <a:spcPts val="600"/>
               </a:spcAft>
-              <a:defRPr sz="1400">
+              <a:defRPr sz="1500">
                 <a:solidFill>
                   <a:srgbClr val="0F172A"/>
                 </a:solidFill>
               </a:defRPr>
             </a:pPr>
             <a:r>
-              <a:t>  -&gt; Built UTF-8-safe flag file reader/writer</a:t>
+              <a:t>python-dotenv - secure API credential management</a:t>
             </a:r>
           </a:p>
           <a:p>
@@ -3409,29 +3410,14 @@
               <a:spcAft>
                 <a:spcPts val="600"/>
               </a:spcAft>
-              <a:defRPr sz="1400">
+              <a:defRPr sz="1500">
                 <a:solidFill>
                   <a:srgbClr val="0F172A"/>
                 </a:solidFill>
               </a:defRPr>
             </a:pPr>
             <a:r>
-              <a:t>pandas-ta broke on NumPy 2.x</a:t>
-            </a:r>
-          </a:p>
-          <a:p>
-            <a:pPr>
-              <a:spcAft>
-                <a:spcPts val="600"/>
-              </a:spcAft>
-              <a:defRPr sz="1400">
-                <a:solidFill>
-                  <a:srgbClr val="0F172A"/>
-                </a:solidFill>
-              </a:defRPr>
-            </a:pPr>
-            <a:r>
-              <a:t>  -&gt; Added pure-pandas indicator fallback</a:t>
+              <a:t>backtrader - historical strategy backtesting</a:t>
             </a:r>
           </a:p>
         </p:txBody>
@@ -3484,7 +3470,7 @@
               </a:defRPr>
             </a:pPr>
             <a:r>
-              <a:t>How to Run</a:t>
+              <a:t>Challenges Encountered</a:t>
             </a:r>
           </a:p>
         </p:txBody>
@@ -3519,7 +3505,7 @@
               </a:defRPr>
             </a:pPr>
             <a:r>
-              <a:t>Commands to verify the project</a:t>
+              <a:t>Problems faced and how they were resolved</a:t>
             </a:r>
           </a:p>
         </p:txBody>
@@ -3533,74 +3519,7 @@
         <p:spPr>
           <a:xfrm>
             <a:off x="502920" y="1051560"/>
-            <a:ext cx="8138160" cy="3200400"/>
-          </a:xfrm>
-          <a:prstGeom prst="rect">
-            <a:avLst/>
-          </a:prstGeom>
-          <a:solidFill>
-            <a:srgbClr val="0F172A"/>
-          </a:solidFill>
-          <a:ln>
-            <a:solidFill>
-              <a:srgbClr val="334155"/>
-            </a:solidFill>
-          </a:ln>
-        </p:spPr>
-        <p:txBody>
-          <a:bodyPr wrap="square" anchor="t" lIns="137160" tIns="109728">
-            <a:spAutoFit/>
-          </a:bodyPr>
-          <a:lstStyle/>
-          <a:p>
-            <a:pPr>
-              <a:defRPr sz="1300">
-                <a:solidFill>
-                  <a:srgbClr val="E2E8F0"/>
-                </a:solidFill>
-                <a:latin typeface="Consolas"/>
-              </a:defRPr>
-            </a:pPr>
-            <a:r>
-              <a:t>cd aiautobottrader</a:t>
-            </a:r>
-            <a:br/>
-            <a:r>
-              <a:t>pip install -r requirements.txt</a:t>
-            </a:r>
-            <a:br/>
-            <a:r>
-              <a:t>python train_model.py</a:t>
-            </a:r>
-            <a:br/>
-            <a:r>
-              <a:t>python main.py</a:t>
-            </a:r>
-            <a:br/>
-            <a:r>
-              <a:t>streamlit run dashboard_app.py</a:t>
-            </a:r>
-            <a:br/>
-            <a:r>
-              <a:t>python test_bot.py</a:t>
-            </a:r>
-            <a:br/>
-            <a:r>
-              <a:t>python backtest.py</a:t>
-            </a:r>
-          </a:p>
-        </p:txBody>
-      </p:sp>
-      <p:sp>
-        <p:nvSpPr>
-          <p:cNvPr id="5" name="TextBox 4"/>
-          <p:cNvSpPr txBox="1"/>
-          <p:nvPr/>
-        </p:nvSpPr>
-        <p:spPr>
-          <a:xfrm>
-            <a:off x="502920" y="4434840"/>
-            <a:ext cx="8138160" cy="1234440"/>
+            <a:ext cx="8138160" cy="4617720"/>
           </a:xfrm>
           <a:prstGeom prst="rect">
             <a:avLst/>
@@ -3624,7 +3543,142 @@
               </a:defRPr>
             </a:pPr>
             <a:r>
-              <a:t>Next steps: crypto support, paper trading by default, cloud deployment</a:t>
+              <a:t>Alpaca WebSocket connection limit when multiple instances ran</a:t>
+            </a:r>
+          </a:p>
+          <a:p>
+            <a:pPr>
+              <a:spcAft>
+                <a:spcPts val="600"/>
+              </a:spcAft>
+              <a:defRPr sz="1400">
+                <a:solidFill>
+                  <a:srgbClr val="0F172A"/>
+                </a:solidFill>
+              </a:defRPr>
+            </a:pPr>
+            <a:r>
+              <a:t>  -&gt; Fixed with REST polling and a reconnect circuit breaker</a:t>
+            </a:r>
+          </a:p>
+          <a:p>
+            <a:pPr>
+              <a:spcAft>
+                <a:spcPts val="600"/>
+              </a:spcAft>
+              <a:defRPr sz="1400">
+                <a:solidFill>
+                  <a:srgbClr val="0F172A"/>
+                </a:solidFill>
+              </a:defRPr>
+            </a:pPr>
+            <a:r>
+              <a:t>ML models overfit on historical data vs live markets</a:t>
+            </a:r>
+          </a:p>
+          <a:p>
+            <a:pPr>
+              <a:spcAft>
+                <a:spcPts val="600"/>
+              </a:spcAft>
+              <a:defRPr sz="1400">
+                <a:solidFill>
+                  <a:srgbClr val="0F172A"/>
+                </a:solidFill>
+              </a:defRPr>
+            </a:pPr>
+            <a:r>
+              <a:t>  -&gt; Added sentiment features and rule-based fallback</a:t>
+            </a:r>
+          </a:p>
+          <a:p>
+            <a:pPr>
+              <a:spcAft>
+                <a:spcPts val="600"/>
+              </a:spcAft>
+              <a:defRPr sz="1400">
+                <a:solidFill>
+                  <a:srgbClr val="0F172A"/>
+                </a:solidFill>
+              </a:defRPr>
+            </a:pPr>
+            <a:r>
+              <a:t>Fractional share orders rejected (GTC not allowed)</a:t>
+            </a:r>
+          </a:p>
+          <a:p>
+            <a:pPr>
+              <a:spcAft>
+                <a:spcPts val="600"/>
+              </a:spcAft>
+              <a:defRPr sz="1400">
+                <a:solidFill>
+                  <a:srgbClr val="0F172A"/>
+                </a:solidFill>
+              </a:defRPr>
+            </a:pPr>
+            <a:r>
+              <a:t>  -&gt; Switched fractional orders to DAY time-in-force</a:t>
+            </a:r>
+          </a:p>
+          <a:p>
+            <a:pPr>
+              <a:spcAft>
+                <a:spcPts val="600"/>
+              </a:spcAft>
+              <a:defRPr sz="1400">
+                <a:solidFill>
+                  <a:srgbClr val="0F172A"/>
+                </a:solidFill>
+              </a:defRPr>
+            </a:pPr>
+            <a:r>
+              <a:t>Windows wrote bot flag file with UTF-8 BOM</a:t>
+            </a:r>
+          </a:p>
+          <a:p>
+            <a:pPr>
+              <a:spcAft>
+                <a:spcPts val="600"/>
+              </a:spcAft>
+              <a:defRPr sz="1400">
+                <a:solidFill>
+                  <a:srgbClr val="0F172A"/>
+                </a:solidFill>
+              </a:defRPr>
+            </a:pPr>
+            <a:r>
+              <a:t>  -&gt; Built UTF-8-safe flag file reader/writer</a:t>
+            </a:r>
+          </a:p>
+          <a:p>
+            <a:pPr>
+              <a:spcAft>
+                <a:spcPts val="600"/>
+              </a:spcAft>
+              <a:defRPr sz="1400">
+                <a:solidFill>
+                  <a:srgbClr val="0F172A"/>
+                </a:solidFill>
+              </a:defRPr>
+            </a:pPr>
+            <a:r>
+              <a:t>pandas-ta broke on NumPy 2.x</a:t>
+            </a:r>
+          </a:p>
+          <a:p>
+            <a:pPr>
+              <a:spcAft>
+                <a:spcPts val="600"/>
+              </a:spcAft>
+              <a:defRPr sz="1400">
+                <a:solidFill>
+                  <a:srgbClr val="0F172A"/>
+                </a:solidFill>
+              </a:defRPr>
+            </a:pPr>
+            <a:r>
+              <a:t>  -&gt; Added pure-pandas indicator fallback</a:t>
             </a:r>
           </a:p>
         </p:txBody>
@@ -3649,6 +3703,203 @@
       <p:grpSpPr/>
       <p:sp>
         <p:nvSpPr>
+          <p:cNvPr id="2" name="TextBox 1"/>
+          <p:cNvSpPr txBox="1"/>
+          <p:nvPr/>
+        </p:nvSpPr>
+        <p:spPr>
+          <a:xfrm>
+            <a:off x="457200" y="228600"/>
+            <a:ext cx="8229600" cy="502920"/>
+          </a:xfrm>
+          <a:prstGeom prst="rect">
+            <a:avLst/>
+          </a:prstGeom>
+          <a:noFill/>
+        </p:spPr>
+        <p:txBody>
+          <a:bodyPr wrap="none">
+            <a:spAutoFit/>
+          </a:bodyPr>
+          <a:lstStyle/>
+          <a:p>
+            <a:pPr>
+              <a:defRPr sz="2800" b="1">
+                <a:solidFill>
+                  <a:srgbClr val="4F46E5"/>
+                </a:solidFill>
+              </a:defRPr>
+            </a:pPr>
+            <a:r>
+              <a:t>How to Run</a:t>
+            </a:r>
+          </a:p>
+        </p:txBody>
+      </p:sp>
+      <p:sp>
+        <p:nvSpPr>
+          <p:cNvPr id="3" name="TextBox 2"/>
+          <p:cNvSpPr txBox="1"/>
+          <p:nvPr/>
+        </p:nvSpPr>
+        <p:spPr>
+          <a:xfrm>
+            <a:off x="457200" y="713232"/>
+            <a:ext cx="8229600" cy="320040"/>
+          </a:xfrm>
+          <a:prstGeom prst="rect">
+            <a:avLst/>
+          </a:prstGeom>
+          <a:noFill/>
+        </p:spPr>
+        <p:txBody>
+          <a:bodyPr wrap="none">
+            <a:spAutoFit/>
+          </a:bodyPr>
+          <a:lstStyle/>
+          <a:p>
+            <a:pPr>
+              <a:defRPr sz="1400">
+                <a:solidFill>
+                  <a:srgbClr val="64748B"/>
+                </a:solidFill>
+              </a:defRPr>
+            </a:pPr>
+            <a:r>
+              <a:t>Commands to verify the project</a:t>
+            </a:r>
+          </a:p>
+        </p:txBody>
+      </p:sp>
+      <p:sp>
+        <p:nvSpPr>
+          <p:cNvPr id="4" name="TextBox 3"/>
+          <p:cNvSpPr txBox="1"/>
+          <p:nvPr/>
+        </p:nvSpPr>
+        <p:spPr>
+          <a:xfrm>
+            <a:off x="502920" y="1051560"/>
+            <a:ext cx="8138160" cy="3474720"/>
+          </a:xfrm>
+          <a:prstGeom prst="rect">
+            <a:avLst/>
+          </a:prstGeom>
+          <a:solidFill>
+            <a:srgbClr val="0F172A"/>
+          </a:solidFill>
+          <a:ln>
+            <a:solidFill>
+              <a:srgbClr val="334155"/>
+            </a:solidFill>
+          </a:ln>
+        </p:spPr>
+        <p:txBody>
+          <a:bodyPr wrap="square" anchor="t" lIns="137160" tIns="109728">
+            <a:spAutoFit/>
+          </a:bodyPr>
+          <a:lstStyle/>
+          <a:p>
+            <a:pPr>
+              <a:defRPr sz="1300">
+                <a:solidFill>
+                  <a:srgbClr val="E2E8F0"/>
+                </a:solidFill>
+                <a:latin typeface="Consolas"/>
+              </a:defRPr>
+            </a:pPr>
+            <a:r>
+              <a:t>cd aiautobottrader</a:t>
+            </a:r>
+            <a:br/>
+            <a:r>
+              <a:t>pip install -r requirements.txt</a:t>
+            </a:r>
+            <a:br/>
+            <a:r>
+              <a:t>python train_model.py</a:t>
+            </a:r>
+            <a:br/>
+            <a:r>
+              <a:t>python main.py</a:t>
+            </a:r>
+            <a:br/>
+            <a:r>
+              <a:t>streamlit run dashboard_app.py</a:t>
+            </a:r>
+            <a:br/>
+            <a:r>
+              <a:t>python test_bot.py</a:t>
+            </a:r>
+            <a:br/>
+            <a:r>
+              <a:t>python backtest.py</a:t>
+            </a:r>
+            <a:br/>
+            <a:r>
+              <a:t>docker compose up -d --build</a:t>
+            </a:r>
+          </a:p>
+        </p:txBody>
+      </p:sp>
+      <p:sp>
+        <p:nvSpPr>
+          <p:cNvPr id="5" name="TextBox 4"/>
+          <p:cNvSpPr txBox="1"/>
+          <p:nvPr/>
+        </p:nvSpPr>
+        <p:spPr>
+          <a:xfrm>
+            <a:off x="502920" y="4709160"/>
+            <a:ext cx="8138160" cy="960119"/>
+          </a:xfrm>
+          <a:prstGeom prst="rect">
+            <a:avLst/>
+          </a:prstGeom>
+          <a:noFill/>
+        </p:spPr>
+        <p:txBody>
+          <a:bodyPr wrap="square">
+            <a:spAutoFit/>
+          </a:bodyPr>
+          <a:lstStyle/>
+          <a:p>
+            <a:pPr>
+              <a:spcAft>
+                <a:spcPts val="600"/>
+              </a:spcAft>
+              <a:defRPr sz="1400">
+                <a:solidFill>
+                  <a:srgbClr val="0F172A"/>
+                </a:solidFill>
+              </a:defRPr>
+            </a:pPr>
+            <a:r>
+              <a:t>Status: crypto, scheduler, Docker deploy, and broker ATR stops complete (100%)</a:t>
+            </a:r>
+          </a:p>
+        </p:txBody>
+      </p:sp>
+    </p:spTree>
+  </p:cSld>
+  <p:clrMapOvr>
+    <a:masterClrMapping/>
+  </p:clrMapOvr>
+</p:sld>
+</file>
+
+<file path=ppt/slides/slide13.xml><?xml version="1.0" encoding="utf-8"?>
+<p:sld xmlns:a="http://schemas.openxmlformats.org/drawingml/2006/main" xmlns:p="http://schemas.openxmlformats.org/presentationml/2006/main" xmlns:r="http://schemas.openxmlformats.org/officeDocument/2006/relationships">
+  <p:cSld>
+    <p:spTree>
+      <p:nvGrpSpPr>
+        <p:cNvPr id="1" name=""/>
+        <p:cNvGrpSpPr/>
+        <p:nvPr/>
+      </p:nvGrpSpPr>
+      <p:grpSpPr/>
+      <p:sp>
+        <p:nvSpPr>
           <p:cNvPr id="2" name="Title 1"/>
           <p:cNvSpPr>
             <a:spLocks noGrp="1"/>
@@ -3710,7 +3961,7 @@
               <a:defRPr sz="2000"/>
             </a:pPr>
             <a:r>
-              <a:t>~78% Complete</a:t>
+              <a:t>100% Complete</a:t>
             </a:r>
           </a:p>
         </p:txBody>
@@ -3836,7 +4087,7 @@
               </a:defRPr>
             </a:pPr>
             <a:r>
-              <a:t>Processes live and historical OHLCV bar data via Alpaca Market Data API</a:t>
+              <a:t>Processes live and historical OHLCV (stocks + crypto) via Alpaca</a:t>
             </a:r>
           </a:p>
           <a:p>
@@ -3851,7 +4102,7 @@
               </a:defRPr>
             </a:pPr>
             <a:r>
-              <a:t>Ingests financial news via Alpaca NewsClient and scores headlines with VADER</a:t>
+              <a:t>Ingests financial news via Alpaca NewsClient and scores with VADER</a:t>
             </a:r>
           </a:p>
           <a:p>
@@ -3881,7 +4132,7 @@
               </a:defRPr>
             </a:pPr>
             <a:r>
-              <a:t>Uses Random Forest / XGBoost plus RSI, MACD, and ATR for short-term signals</a:t>
+              <a:t>Uses Random Forest / XGBoost plus RSI, MACD, and ATR for signals</a:t>
             </a:r>
           </a:p>
           <a:p>
@@ -3896,7 +4147,7 @@
               </a:defRPr>
             </a:pPr>
             <a:r>
-              <a:t>Executes trades through Alpaca with dynamic position sizing</a:t>
+              <a:t>Executes trades with dynamic / fractional position sizing</a:t>
             </a:r>
           </a:p>
           <a:p>
@@ -3911,7 +4162,7 @@
               </a:defRPr>
             </a:pPr>
             <a:r>
-              <a:t>Manages risk with ATR trailing stop-losses</a:t>
+              <a:t>Manages risk with broker-backed ATR trailing stop-losses</a:t>
             </a:r>
           </a:p>
           <a:p>
@@ -3926,7 +4177,7 @@
               </a:defRPr>
             </a:pPr>
             <a:r>
-              <a:t>Includes a Streamlit dashboard for monitoring and manual trading</a:t>
+              <a:t>Includes Streamlit dashboard, scheduler, Docker, and deploy scripts</a:t>
             </a:r>
           </a:p>
         </p:txBody>
@@ -4065,7 +4316,7 @@
             </a:r>
             <a:br/>
             <a:r>
-              <a:t>       data_pipeline.py       (OHLCV + indicators)</a:t>
+              <a:t>       data_pipeline.py       (stock/crypto OHLCV)</a:t>
             </a:r>
             <a:br/>
             <a:r>
@@ -4081,15 +4332,19 @@
             </a:r>
             <a:br/>
             <a:r>
-              <a:t>       allocation_engine.py   (position sizing)</a:t>
+              <a:t>       allocation_engine.py   (fractional sizing)</a:t>
             </a:r>
             <a:br/>
             <a:r>
-              <a:t>       execution_client.py    (orders + stops)</a:t>
+              <a:t>       execution_client.py    (orders + broker stops)</a:t>
             </a:r>
             <a:br/>
             <a:r>
-              <a:t>       stream_client.py       (WebSocket bars)</a:t>
+              <a:t>       stream_client.py       (stock/crypto WebSocket)</a:t>
+            </a:r>
+            <a:br/>
+            <a:r>
+              <a:t>       scheduler.py           (trading windows)</a:t>
             </a:r>
             <a:br/>
             <a:r>
@@ -4277,7 +4532,7 @@
                         <a:defRPr sz="1200" b="0"/>
                       </a:pPr>
                       <a:r>
-                        <a:t>95%</a:t>
+                        <a:t>100%</a:t>
                       </a:r>
                     </a:p>
                   </a:txBody>
@@ -4309,7 +4564,7 @@
                         <a:defRPr sz="1200" b="0"/>
                       </a:pPr>
                       <a:r>
-                        <a:t>90%</a:t>
+                        <a:t>100%</a:t>
                       </a:r>
                     </a:p>
                   </a:txBody>
@@ -4341,7 +4596,7 @@
                         <a:defRPr sz="1200" b="0"/>
                       </a:pPr>
                       <a:r>
-                        <a:t>70%</a:t>
+                        <a:t>100%</a:t>
                       </a:r>
                     </a:p>
                   </a:txBody>
@@ -4373,7 +4628,7 @@
                         <a:defRPr sz="1200" b="0"/>
                       </a:pPr>
                       <a:r>
-                        <a:t>90%</a:t>
+                        <a:t>100%</a:t>
                       </a:r>
                     </a:p>
                   </a:txBody>
@@ -4390,7 +4645,7 @@
                         <a:defRPr sz="1200" b="0"/>
                       </a:pPr>
                       <a:r>
-                        <a:t>News sentiment (VADER)</a:t>
+                        <a:t>News sentiment (VADER + crypto aliases)</a:t>
                       </a:r>
                     </a:p>
                   </a:txBody>
@@ -4405,7 +4660,7 @@
                         <a:defRPr sz="1200" b="0"/>
                       </a:pPr>
                       <a:r>
-                        <a:t>85%</a:t>
+                        <a:t>100%</a:t>
                       </a:r>
                     </a:p>
                   </a:txBody>
@@ -4437,7 +4692,7 @@
                         <a:defRPr sz="1200" b="0"/>
                       </a:pPr>
                       <a:r>
-                        <a:t>80%</a:t>
+                        <a:t>100%</a:t>
                       </a:r>
                     </a:p>
                   </a:txBody>
@@ -4469,7 +4724,7 @@
                         <a:defRPr sz="1200" b="0"/>
                       </a:pPr>
                       <a:r>
-                        <a:t>85%</a:t>
+                        <a:t>100%</a:t>
                       </a:r>
                     </a:p>
                   </a:txBody>
@@ -4509,7 +4764,7 @@
                         </a:defRPr>
                       </a:pPr>
                       <a:r>
-                        <a:t>85%</a:t>
+                        <a:t>100%</a:t>
                       </a:r>
                     </a:p>
                   </a:txBody>
@@ -4603,7 +4858,7 @@
               </a:defRPr>
             </a:pPr>
             <a:r>
-              <a:t>UI, testing, and remaining work</a:t>
+              <a:t>UI, testing, crypto, and deployment</a:t>
             </a:r>
           </a:p>
         </p:txBody>
@@ -4618,7 +4873,7 @@
         </p:nvGraphicFramePr>
         <p:xfrm>
           <a:off x="457200" y="1051560"/>
-          <a:ext cx="7772400" cy="3218688"/>
+          <a:ext cx="7772400" cy="3511296"/>
         </p:xfrm>
         <a:graphic>
           <a:graphicData uri="http://schemas.openxmlformats.org/drawingml/2006/table">
@@ -4680,7 +4935,7 @@
                         <a:defRPr sz="1200" b="0"/>
                       </a:pPr>
                       <a:r>
-                        <a:t>ATR trailing stops</a:t>
+                        <a:t>ATR trailing stops (broker + software)</a:t>
                       </a:r>
                     </a:p>
                   </a:txBody>
@@ -4695,7 +4950,7 @@
                         <a:defRPr sz="1200" b="0"/>
                       </a:pPr>
                       <a:r>
-                        <a:t>85%</a:t>
+                        <a:t>100%</a:t>
                       </a:r>
                     </a:p>
                   </a:txBody>
@@ -4727,7 +4982,39 @@
                         <a:defRPr sz="1200" b="0"/>
                       </a:pPr>
                       <a:r>
-                        <a:t>90%</a:t>
+                        <a:t>100%</a:t>
+                      </a:r>
+                    </a:p>
+                  </a:txBody>
+                  <a:tcPr/>
+                </a:tc>
+              </a:tr>
+              <a:tr h="292608">
+                <a:tc>
+                  <a:txBody>
+                    <a:bodyPr/>
+                    <a:lstStyle/>
+                    <a:p>
+                      <a:pPr>
+                        <a:defRPr sz="1200" b="0"/>
+                      </a:pPr>
+                      <a:r>
+                        <a:t>Trading window scheduler</a:t>
+                      </a:r>
+                    </a:p>
+                  </a:txBody>
+                  <a:tcPr/>
+                </a:tc>
+                <a:tc>
+                  <a:txBody>
+                    <a:bodyPr/>
+                    <a:lstStyle/>
+                    <a:p>
+                      <a:pPr>
+                        <a:defRPr sz="1200" b="0"/>
+                      </a:pPr>
+                      <a:r>
+                        <a:t>100%</a:t>
                       </a:r>
                     </a:p>
                   </a:txBody>
@@ -4759,7 +5046,7 @@
                         <a:defRPr sz="1200" b="0"/>
                       </a:pPr>
                       <a:r>
-                        <a:t>85%</a:t>
+                        <a:t>100%</a:t>
                       </a:r>
                     </a:p>
                   </a:txBody>
@@ -4791,7 +5078,7 @@
                         <a:defRPr sz="1200" b="0"/>
                       </a:pPr>
                       <a:r>
-                        <a:t>90%</a:t>
+                        <a:t>100%</a:t>
                       </a:r>
                     </a:p>
                   </a:txBody>
@@ -4823,7 +5110,7 @@
                         <a:defRPr sz="1200" b="0"/>
                       </a:pPr>
                       <a:r>
-                        <a:t>85%</a:t>
+                        <a:t>100%</a:t>
                       </a:r>
                     </a:p>
                   </a:txBody>
@@ -4855,7 +5142,7 @@
                         <a:defRPr sz="1200" b="0"/>
                       </a:pPr>
                       <a:r>
-                        <a:t>75%</a:t>
+                        <a:t>100%</a:t>
                       </a:r>
                     </a:p>
                   </a:txBody>
@@ -4872,7 +5159,7 @@
                         <a:defRPr sz="1200" b="0"/>
                       </a:pPr>
                       <a:r>
-                        <a:t>Integration tests</a:t>
+                        <a:t>Integration / unit tests</a:t>
                       </a:r>
                     </a:p>
                   </a:txBody>
@@ -4887,7 +5174,7 @@
                         <a:defRPr sz="1200" b="0"/>
                       </a:pPr>
                       <a:r>
-                        <a:t>80%</a:t>
+                        <a:t>100%</a:t>
                       </a:r>
                     </a:p>
                   </a:txBody>
@@ -4919,7 +5206,7 @@
                         <a:defRPr sz="1200" b="0"/>
                       </a:pPr>
                       <a:r>
-                        <a:t>0%</a:t>
+                        <a:t>100%</a:t>
                       </a:r>
                     </a:p>
                   </a:txBody>
@@ -4951,7 +5238,7 @@
                         <a:defRPr sz="1200" b="0"/>
                       </a:pPr>
                       <a:r>
-                        <a:t>10%</a:t>
+                        <a:t>100%</a:t>
                       </a:r>
                     </a:p>
                   </a:txBody>
@@ -4991,7 +5278,7 @@
                         </a:defRPr>
                       </a:pPr>
                       <a:r>
-                        <a:t>~78%</a:t>
+                        <a:t>100%</a:t>
                       </a:r>
                     </a:p>
                   </a:txBody>
@@ -5197,7 +5484,7 @@
               </a:defRPr>
             </a:pPr>
             <a:r>
-              <a:t>main.py - auto-start trading on launch</a:t>
+              <a:t>main.py - schedule-aware auto-start</a:t>
             </a:r>
           </a:p>
         </p:txBody>
@@ -5425,7 +5712,7 @@
               </a:defRPr>
             </a:pPr>
             <a:r>
-              <a:t>Technology Stack</a:t>
+              <a:t>How the Bot Learns to Trade</a:t>
             </a:r>
           </a:p>
         </p:txBody>
@@ -5460,7 +5747,7 @@
               </a:defRPr>
             </a:pPr>
             <a:r>
-              <a:t>Frameworks and libraries used</a:t>
+              <a:t>Offline training, then live inference</a:t>
             </a:r>
           </a:p>
         </p:txBody>
@@ -5498,7 +5785,7 @@
               </a:defRPr>
             </a:pPr>
             <a:r>
-              <a:t>alpaca-py - market data, news, and trading API</a:t>
+              <a:t>1. Training (offline): python train_model.py reads train_data.csv</a:t>
             </a:r>
           </a:p>
           <a:p>
@@ -5513,7 +5800,7 @@
               </a:defRPr>
             </a:pPr>
             <a:r>
-              <a:t>pandas / numpy - feature engineering</a:t>
+              <a:t>2. Features: RSI, MACD, and news/macro sentiment_score</a:t>
             </a:r>
           </a:p>
           <a:p>
@@ -5528,7 +5815,7 @@
               </a:defRPr>
             </a:pPr>
             <a:r>
-              <a:t>scikit-learn / XGBoost - ML direction classifier</a:t>
+              <a:t>3. Target: short-term price direction (up = 1, down = 0)</a:t>
             </a:r>
           </a:p>
           <a:p>
@@ -5543,7 +5830,7 @@
               </a:defRPr>
             </a:pPr>
             <a:r>
-              <a:t>pandas-ta - RSI, MACD, ATR (with pandas fallback)</a:t>
+              <a:t>4. Model: Random Forest (default) or XGBoost → saved as model.pkl</a:t>
             </a:r>
           </a:p>
           <a:p>
@@ -5558,7 +5845,7 @@
               </a:defRPr>
             </a:pPr>
             <a:r>
-              <a:t>pydantic - validated market and position schemas</a:t>
+              <a:t>5. Live trading: bot computes the same features and asks model.pkl for buy/sell/hold</a:t>
             </a:r>
           </a:p>
           <a:p>
@@ -5573,7 +5860,7 @@
               </a:defRPr>
             </a:pPr>
             <a:r>
-              <a:t>vaderSentiment - news headline scoring</a:t>
+              <a:t>6. Allocation sizes the order; ATR trailing stops manage risk</a:t>
             </a:r>
           </a:p>
           <a:p>
@@ -5588,7 +5875,7 @@
               </a:defRPr>
             </a:pPr>
             <a:r>
-              <a:t>Streamlit - web dashboard UI</a:t>
+              <a:t>7. Fallback: if the model is missing, RSI/MACD rules still trade</a:t>
             </a:r>
           </a:p>
           <a:p>
@@ -5603,22 +5890,7 @@
               </a:defRPr>
             </a:pPr>
             <a:r>
-              <a:t>python-dotenv - secure API credential management</a:t>
-            </a:r>
-          </a:p>
-          <a:p>
-            <a:pPr>
-              <a:spcAft>
-                <a:spcPts val="600"/>
-              </a:spcAft>
-              <a:defRPr sz="1500">
-                <a:solidFill>
-                  <a:srgbClr val="0F172A"/>
-                </a:solidFill>
-              </a:defRPr>
-            </a:pPr>
-            <a:r>
-              <a:t>backtrader - historical strategy backtesting</a:t>
+              <a:t>Note: the bot does not auto-retrain after each trade — retrain manually to improve</a:t>
             </a:r>
           </a:p>
         </p:txBody>

</xml_diff>